<commit_message>
docs: add flowchart for loading fused plan.bin at GetWorkspaceSize
Co-authored-by: 69515164-rgb <69515164-rgb@users.noreply.github.com>
</commit_message>
<xml_diff>
--- a/docs/融合算子自动生成_MM_AllReduce.pptx
+++ b/docs/融合算子自动生成_MM_AllReduce.pptx
@@ -16115,7 +16115,7 @@
                 <a:latin typeface="Droid Sans Fallback"/>
               </a:rPr>
               <a:t>tiling + produce 边
-必给；dur 仅离线可选</a:t>
+950：可见层=UB Memory</a:t>
             </a:r>
           </a:p>
         </p:txBody>
@@ -16310,8 +16310,8 @@
                 </a:solidFill>
                 <a:latin typeface="Droid Sans Fallback"/>
               </a:rPr>
-              <a:t>挂写完事件再 post
-禁止定时器启动</a:t>
+              <a:t>槽写完再 post UB WQE
+走 CCU_SCHED，禁闹钟</a:t>
             </a:r>
           </a:p>
         </p:txBody>
@@ -16972,8 +16972,8 @@
         </p:nvSpPr>
         <p:spPr>
           <a:xfrm>
-            <a:off x="640080" y="1060704"/>
-            <a:ext cx="3017520" cy="420624"/>
+            <a:off x="640080" y="1024128"/>
+            <a:ext cx="3017520" cy="384048"/>
           </a:xfrm>
           <a:prstGeom prst="rect">
             <a:avLst/>
@@ -17007,8 +17007,8 @@
         </p:nvSpPr>
         <p:spPr>
           <a:xfrm>
-            <a:off x="3749039" y="1060704"/>
-            <a:ext cx="7772400" cy="420624"/>
+            <a:off x="3749039" y="1024128"/>
+            <a:ext cx="7772400" cy="384048"/>
           </a:xfrm>
           <a:prstGeom prst="rect">
             <a:avLst/>
@@ -17042,8 +17042,8 @@
         </p:nvSpPr>
         <p:spPr>
           <a:xfrm>
-            <a:off x="640080" y="1554480"/>
-            <a:ext cx="3017520" cy="420624"/>
+            <a:off x="640080" y="1463040"/>
+            <a:ext cx="3017520" cy="384048"/>
           </a:xfrm>
           <a:prstGeom prst="rect">
             <a:avLst/>
@@ -17077,8 +17077,8 @@
         </p:nvSpPr>
         <p:spPr>
           <a:xfrm>
-            <a:off x="3749039" y="1554480"/>
-            <a:ext cx="7772400" cy="420624"/>
+            <a:off x="3749039" y="1463040"/>
+            <a:ext cx="7772400" cy="384048"/>
           </a:xfrm>
           <a:prstGeom prst="rect">
             <a:avLst/>
@@ -17112,8 +17112,8 @@
         </p:nvSpPr>
         <p:spPr>
           <a:xfrm>
-            <a:off x="640080" y="2048256"/>
-            <a:ext cx="3017520" cy="420624"/>
+            <a:off x="640080" y="1901952"/>
+            <a:ext cx="3017520" cy="384048"/>
           </a:xfrm>
           <a:prstGeom prst="rect">
             <a:avLst/>
@@ -17147,8 +17147,8 @@
         </p:nvSpPr>
         <p:spPr>
           <a:xfrm>
-            <a:off x="3749039" y="2048256"/>
-            <a:ext cx="7772400" cy="420624"/>
+            <a:off x="3749039" y="1901952"/>
+            <a:ext cx="7772400" cy="384048"/>
           </a:xfrm>
           <a:prstGeom prst="rect">
             <a:avLst/>
@@ -17182,8 +17182,8 @@
         </p:nvSpPr>
         <p:spPr>
           <a:xfrm>
-            <a:off x="640080" y="2542032"/>
-            <a:ext cx="3017520" cy="420624"/>
+            <a:off x="640080" y="2340864"/>
+            <a:ext cx="3017520" cy="384048"/>
           </a:xfrm>
           <a:prstGeom prst="rect">
             <a:avLst/>
@@ -17217,8 +17217,8 @@
         </p:nvSpPr>
         <p:spPr>
           <a:xfrm>
-            <a:off x="3749039" y="2542032"/>
-            <a:ext cx="7772400" cy="420624"/>
+            <a:off x="3749039" y="2340864"/>
+            <a:ext cx="7772400" cy="384048"/>
           </a:xfrm>
           <a:prstGeom prst="rect">
             <a:avLst/>
@@ -17252,8 +17252,8 @@
         </p:nvSpPr>
         <p:spPr>
           <a:xfrm>
-            <a:off x="640080" y="3035808"/>
-            <a:ext cx="3017520" cy="420624"/>
+            <a:off x="640080" y="2779776"/>
+            <a:ext cx="3017520" cy="384048"/>
           </a:xfrm>
           <a:prstGeom prst="rect">
             <a:avLst/>
@@ -17287,8 +17287,8 @@
         </p:nvSpPr>
         <p:spPr>
           <a:xfrm>
-            <a:off x="3749039" y="3035808"/>
-            <a:ext cx="7772400" cy="420624"/>
+            <a:off x="3749039" y="2779776"/>
+            <a:ext cx="7772400" cy="384048"/>
           </a:xfrm>
           <a:prstGeom prst="rect">
             <a:avLst/>
@@ -17322,8 +17322,8 @@
         </p:nvSpPr>
         <p:spPr>
           <a:xfrm>
-            <a:off x="640080" y="3529584"/>
-            <a:ext cx="3017520" cy="420624"/>
+            <a:off x="640080" y="3218688"/>
+            <a:ext cx="3017520" cy="384048"/>
           </a:xfrm>
           <a:prstGeom prst="rect">
             <a:avLst/>
@@ -17357,8 +17357,8 @@
         </p:nvSpPr>
         <p:spPr>
           <a:xfrm>
-            <a:off x="3749039" y="3529584"/>
-            <a:ext cx="7772400" cy="420624"/>
+            <a:off x="3749039" y="3218688"/>
+            <a:ext cx="7772400" cy="384048"/>
           </a:xfrm>
           <a:prstGeom prst="rect">
             <a:avLst/>
@@ -17392,8 +17392,8 @@
         </p:nvSpPr>
         <p:spPr>
           <a:xfrm>
-            <a:off x="640080" y="4023360"/>
-            <a:ext cx="3017520" cy="420624"/>
+            <a:off x="640080" y="3657600"/>
+            <a:ext cx="3017520" cy="384048"/>
           </a:xfrm>
           <a:prstGeom prst="rect">
             <a:avLst/>
@@ -17427,8 +17427,8 @@
         </p:nvSpPr>
         <p:spPr>
           <a:xfrm>
-            <a:off x="3749039" y="4023360"/>
-            <a:ext cx="7772400" cy="420624"/>
+            <a:off x="3749039" y="3657600"/>
+            <a:ext cx="7772400" cy="384048"/>
           </a:xfrm>
           <a:prstGeom prst="rect">
             <a:avLst/>
@@ -17462,8 +17462,8 @@
         </p:nvSpPr>
         <p:spPr>
           <a:xfrm>
-            <a:off x="640080" y="4517136"/>
-            <a:ext cx="3017520" cy="420624"/>
+            <a:off x="640080" y="4096512"/>
+            <a:ext cx="3017520" cy="384048"/>
           </a:xfrm>
           <a:prstGeom prst="rect">
             <a:avLst/>
@@ -17497,8 +17497,8 @@
         </p:nvSpPr>
         <p:spPr>
           <a:xfrm>
-            <a:off x="3749039" y="4517136"/>
-            <a:ext cx="7772400" cy="420624"/>
+            <a:off x="3749039" y="4096512"/>
+            <a:ext cx="7772400" cy="384048"/>
           </a:xfrm>
           <a:prstGeom prst="rect">
             <a:avLst/>
@@ -17532,8 +17532,8 @@
         </p:nvSpPr>
         <p:spPr>
           <a:xfrm>
-            <a:off x="640080" y="5010912"/>
-            <a:ext cx="3017520" cy="420624"/>
+            <a:off x="640080" y="4535424"/>
+            <a:ext cx="3017520" cy="384048"/>
           </a:xfrm>
           <a:prstGeom prst="rect">
             <a:avLst/>
@@ -17567,8 +17567,8 @@
         </p:nvSpPr>
         <p:spPr>
           <a:xfrm>
-            <a:off x="3749039" y="5010912"/>
-            <a:ext cx="7772400" cy="420624"/>
+            <a:off x="3749039" y="4535424"/>
+            <a:ext cx="7772400" cy="384048"/>
           </a:xfrm>
           <a:prstGeom prst="rect">
             <a:avLst/>
@@ -17602,8 +17602,8 @@
         </p:nvSpPr>
         <p:spPr>
           <a:xfrm>
-            <a:off x="640080" y="5504688"/>
-            <a:ext cx="3017520" cy="420624"/>
+            <a:off x="640080" y="4974336"/>
+            <a:ext cx="3017520" cy="384048"/>
           </a:xfrm>
           <a:prstGeom prst="rect">
             <a:avLst/>
@@ -17637,8 +17637,8 @@
         </p:nvSpPr>
         <p:spPr>
           <a:xfrm>
-            <a:off x="3749039" y="5504688"/>
-            <a:ext cx="7772400" cy="420624"/>
+            <a:off x="3749039" y="4974336"/>
+            <a:ext cx="7772400" cy="384048"/>
           </a:xfrm>
           <a:prstGeom prst="rect">
             <a:avLst/>
@@ -17660,6 +17660,146 @@
                 <a:latin typeface="Droid Sans Fallback"/>
               </a:rPr>
               <a:t>AllReduce 的两种经典传法；本方案建议给定、不搜</a:t>
+            </a:r>
+          </a:p>
+        </p:txBody>
+      </p:sp>
+      <p:sp>
+        <p:nvSpPr>
+          <p:cNvPr id="26" name="TextBox 25"/>
+          <p:cNvSpPr txBox="1"/>
+          <p:nvPr/>
+        </p:nvSpPr>
+        <p:spPr>
+          <a:xfrm>
+            <a:off x="640080" y="5413248"/>
+            <a:ext cx="3017520" cy="384048"/>
+          </a:xfrm>
+          <a:prstGeom prst="rect">
+            <a:avLst/>
+          </a:prstGeom>
+          <a:noFill/>
+        </p:spPr>
+        <p:txBody>
+          <a:bodyPr wrap="square" anchor="ctr">
+            <a:spAutoFit/>
+          </a:bodyPr>
+          <a:lstStyle/>
+          <a:p>
+            <a:pPr algn="l"/>
+            <a:r>
+              <a:rPr sz="1200" b="1">
+                <a:solidFill>
+                  <a:srgbClr val="25C8DD"/>
+                </a:solidFill>
+                <a:latin typeface="Droid Sans Fallback"/>
+              </a:rPr>
+              <a:t>UB Memory</a:t>
+            </a:r>
+          </a:p>
+        </p:txBody>
+      </p:sp>
+      <p:sp>
+        <p:nvSpPr>
+          <p:cNvPr id="27" name="TextBox 26"/>
+          <p:cNvSpPr txBox="1"/>
+          <p:nvPr/>
+        </p:nvSpPr>
+        <p:spPr>
+          <a:xfrm>
+            <a:off x="3749039" y="5413248"/>
+            <a:ext cx="7772400" cy="384048"/>
+          </a:xfrm>
+          <a:prstGeom prst="rect">
+            <a:avLst/>
+          </a:prstGeom>
+          <a:noFill/>
+        </p:spPr>
+        <p:txBody>
+          <a:bodyPr wrap="square" anchor="ctr">
+            <a:spAutoFit/>
+          </a:bodyPr>
+          <a:lstStyle/>
+          <a:p>
+            <a:pPr algn="l"/>
+            <a:r>
+              <a:rPr sz="1300" b="0">
+                <a:solidFill>
+                  <a:srgbClr val="E5ECF5"/>
+                </a:solidFill>
+                <a:latin typeface="Droid Sans Fallback"/>
+              </a:rPr>
+              <a:t>950 上通信可见的片上槽；Y_partial 写这里，不写 HBM</a:t>
+            </a:r>
+          </a:p>
+        </p:txBody>
+      </p:sp>
+      <p:sp>
+        <p:nvSpPr>
+          <p:cNvPr id="28" name="TextBox 27"/>
+          <p:cNvSpPr txBox="1"/>
+          <p:nvPr/>
+        </p:nvSpPr>
+        <p:spPr>
+          <a:xfrm>
+            <a:off x="640080" y="5852159"/>
+            <a:ext cx="3017520" cy="384048"/>
+          </a:xfrm>
+          <a:prstGeom prst="rect">
+            <a:avLst/>
+          </a:prstGeom>
+          <a:noFill/>
+        </p:spPr>
+        <p:txBody>
+          <a:bodyPr wrap="square" anchor="ctr">
+            <a:spAutoFit/>
+          </a:bodyPr>
+          <a:lstStyle/>
+          <a:p>
+            <a:pPr algn="l"/>
+            <a:r>
+              <a:rPr sz="1200" b="1">
+                <a:solidFill>
+                  <a:srgbClr val="25C8DD"/>
+                </a:solidFill>
+                <a:latin typeface="Droid Sans Fallback"/>
+              </a:rPr>
+              <a:t>CCU_SCHED</a:t>
+            </a:r>
+          </a:p>
+        </p:txBody>
+      </p:sp>
+      <p:sp>
+        <p:nvSpPr>
+          <p:cNvPr id="29" name="TextBox 28"/>
+          <p:cNvSpPr txBox="1"/>
+          <p:nvPr/>
+        </p:nvSpPr>
+        <p:spPr>
+          <a:xfrm>
+            <a:off x="3749039" y="5852159"/>
+            <a:ext cx="7772400" cy="384048"/>
+          </a:xfrm>
+          <a:prstGeom prst="rect">
+            <a:avLst/>
+          </a:prstGeom>
+          <a:noFill/>
+        </p:spPr>
+        <p:txBody>
+          <a:bodyPr wrap="square" anchor="ctr">
+            <a:spAutoFit/>
+          </a:bodyPr>
+          <a:lstStyle/>
+          <a:p>
+            <a:pPr algn="l"/>
+            <a:r>
+              <a:rPr sz="1300" b="0">
+                <a:solidFill>
+                  <a:srgbClr val="E5ECF5"/>
+                </a:solidFill>
+                <a:latin typeface="Droid Sans Fallback"/>
+              </a:rPr>
+              <a:t>片上直传展开模式；默认 AICPU_TS 是 HBM↔HBM，不当主路径</a:t>
             </a:r>
           </a:p>
         </p:txBody>

</xml_diff>